<commit_message>
Added Guandong stuff to presentation 7
</commit_message>
<xml_diff>
--- a/Presentations/Week_7_Presentation.pptx
+++ b/Presentations/Week_7_Presentation.pptx
@@ -5,10 +5,10 @@
     <p:sldMasterId id="2147483648" r:id="rId4"/>
   </p:sldMasterIdLst>
   <p:notesMasterIdLst>
-    <p:notesMasterId r:id="rId24"/>
+    <p:notesMasterId r:id="rId26"/>
   </p:notesMasterIdLst>
   <p:handoutMasterIdLst>
-    <p:handoutMasterId r:id="rId25"/>
+    <p:handoutMasterId r:id="rId27"/>
   </p:handoutMasterIdLst>
   <p:sldIdLst>
     <p:sldId id="305" r:id="rId5"/>
@@ -26,10 +26,12 @@
     <p:sldId id="353" r:id="rId17"/>
     <p:sldId id="352" r:id="rId18"/>
     <p:sldId id="343" r:id="rId19"/>
-    <p:sldId id="345" r:id="rId20"/>
-    <p:sldId id="331" r:id="rId21"/>
-    <p:sldId id="330" r:id="rId22"/>
-    <p:sldId id="318" r:id="rId23"/>
+    <p:sldId id="354" r:id="rId20"/>
+    <p:sldId id="355" r:id="rId21"/>
+    <p:sldId id="345" r:id="rId22"/>
+    <p:sldId id="331" r:id="rId23"/>
+    <p:sldId id="330" r:id="rId24"/>
+    <p:sldId id="318" r:id="rId25"/>
   </p:sldIdLst>
   <p:sldSz cx="12192000" cy="6858000"/>
   <p:notesSz cx="6858000" cy="9144000"/>
@@ -11476,6 +11478,240 @@
   <p:cSld>
     <p:spTree>
       <p:nvGrpSpPr>
+        <p:cNvPr id="1" name=""/>
+        <p:cNvGrpSpPr/>
+        <p:nvPr/>
+      </p:nvGrpSpPr>
+      <p:grpSpPr>
+        <a:xfrm>
+          <a:off x="0" y="0"/>
+          <a:ext cx="0" cy="0"/>
+          <a:chOff x="0" y="0"/>
+          <a:chExt cx="0" cy="0"/>
+        </a:xfrm>
+      </p:grpSpPr>
+      <p:sp>
+        <p:nvSpPr>
+          <p:cNvPr id="2" name="Title 1">
+            <a:extLst>
+              <a:ext uri="{FF2B5EF4-FFF2-40B4-BE49-F238E27FC236}">
+                <a16:creationId xmlns:a16="http://schemas.microsoft.com/office/drawing/2014/main" id="{F8C82EE2-EEFF-C23B-1E0F-BD0F542A90BE}"/>
+              </a:ext>
+            </a:extLst>
+          </p:cNvPr>
+          <p:cNvSpPr>
+            <a:spLocks noGrp="1"/>
+          </p:cNvSpPr>
+          <p:nvPr>
+            <p:ph type="title"/>
+          </p:nvPr>
+        </p:nvSpPr>
+        <p:spPr/>
+        <p:txBody>
+          <a:bodyPr/>
+          <a:lstStyle/>
+          <a:p>
+            <a:r>
+              <a:rPr lang="en-US" dirty="0"/>
+              <a:t>Simulation</a:t>
+            </a:r>
+          </a:p>
+        </p:txBody>
+      </p:sp>
+      <p:pic>
+        <p:nvPicPr>
+          <p:cNvPr id="6" name="Content Placeholder 5" descr="A screenshot of a computer program&#10;&#10;AI-generated content may be incorrect.">
+            <a:extLst>
+              <a:ext uri="{FF2B5EF4-FFF2-40B4-BE49-F238E27FC236}">
+                <a16:creationId xmlns:a16="http://schemas.microsoft.com/office/drawing/2014/main" id="{24907BEB-BC52-D2F7-1119-716AB7BEC0E9}"/>
+              </a:ext>
+            </a:extLst>
+          </p:cNvPr>
+          <p:cNvPicPr>
+            <a:picLocks noGrp="1" noChangeAspect="1"/>
+          </p:cNvPicPr>
+          <p:nvPr>
+            <p:ph sz="quarter" idx="13"/>
+          </p:nvPr>
+        </p:nvPicPr>
+        <p:blipFill>
+          <a:blip r:embed="rId2"/>
+          <a:stretch>
+            <a:fillRect/>
+          </a:stretch>
+        </p:blipFill>
+        <p:spPr>
+          <a:xfrm>
+            <a:off x="1202979" y="1299513"/>
+            <a:ext cx="9312621" cy="4945355"/>
+          </a:xfrm>
+        </p:spPr>
+      </p:pic>
+      <p:sp>
+        <p:nvSpPr>
+          <p:cNvPr id="4" name="Slide Number Placeholder 3">
+            <a:extLst>
+              <a:ext uri="{FF2B5EF4-FFF2-40B4-BE49-F238E27FC236}">
+                <a16:creationId xmlns:a16="http://schemas.microsoft.com/office/drawing/2014/main" id="{94F012A9-C0A1-44EF-BD2C-4E37135BD45F}"/>
+              </a:ext>
+            </a:extLst>
+          </p:cNvPr>
+          <p:cNvSpPr>
+            <a:spLocks noGrp="1"/>
+          </p:cNvSpPr>
+          <p:nvPr>
+            <p:ph type="sldNum" sz="quarter" idx="11"/>
+          </p:nvPr>
+        </p:nvSpPr>
+        <p:spPr/>
+        <p:txBody>
+          <a:bodyPr/>
+          <a:lstStyle/>
+          <a:p>
+            <a:fld id="{B67B645E-C5E5-4727-B977-D372A0AA71D9}" type="slidenum">
+              <a:rPr lang="en-US" smtClean="0"/>
+              <a:pPr/>
+              <a:t>16</a:t>
+            </a:fld>
+            <a:endParaRPr lang="en-US" dirty="0"/>
+          </a:p>
+        </p:txBody>
+      </p:sp>
+    </p:spTree>
+    <p:extLst>
+      <p:ext uri="{BB962C8B-B14F-4D97-AF65-F5344CB8AC3E}">
+        <p14:creationId xmlns:p14="http://schemas.microsoft.com/office/powerpoint/2010/main" val="108195520"/>
+      </p:ext>
+    </p:extLst>
+  </p:cSld>
+  <p:clrMapOvr>
+    <a:masterClrMapping/>
+  </p:clrMapOvr>
+</p:sld>
+</file>
+
+<file path=ppt/slides/slide17.xml><?xml version="1.0" encoding="utf-8"?>
+<p:sld xmlns:a="http://schemas.openxmlformats.org/drawingml/2006/main" xmlns:r="http://schemas.openxmlformats.org/officeDocument/2006/relationships" xmlns:p="http://schemas.openxmlformats.org/presentationml/2006/main">
+  <p:cSld>
+    <p:spTree>
+      <p:nvGrpSpPr>
+        <p:cNvPr id="1" name=""/>
+        <p:cNvGrpSpPr/>
+        <p:nvPr/>
+      </p:nvGrpSpPr>
+      <p:grpSpPr>
+        <a:xfrm>
+          <a:off x="0" y="0"/>
+          <a:ext cx="0" cy="0"/>
+          <a:chOff x="0" y="0"/>
+          <a:chExt cx="0" cy="0"/>
+        </a:xfrm>
+      </p:grpSpPr>
+      <p:sp>
+        <p:nvSpPr>
+          <p:cNvPr id="2" name="Title 1">
+            <a:extLst>
+              <a:ext uri="{FF2B5EF4-FFF2-40B4-BE49-F238E27FC236}">
+                <a16:creationId xmlns:a16="http://schemas.microsoft.com/office/drawing/2014/main" id="{76D3C611-5B79-FFE4-35B2-367640840AD0}"/>
+              </a:ext>
+            </a:extLst>
+          </p:cNvPr>
+          <p:cNvSpPr>
+            <a:spLocks noGrp="1"/>
+          </p:cNvSpPr>
+          <p:nvPr>
+            <p:ph type="title"/>
+          </p:nvPr>
+        </p:nvSpPr>
+        <p:spPr/>
+        <p:txBody>
+          <a:bodyPr/>
+          <a:lstStyle/>
+          <a:p>
+            <a:r>
+              <a:rPr lang="en-US" dirty="0"/>
+              <a:t>DC-DC Converter</a:t>
+            </a:r>
+          </a:p>
+        </p:txBody>
+      </p:sp>
+      <p:pic>
+        <p:nvPicPr>
+          <p:cNvPr id="6" name="Content Placeholder 5" descr="A computer chip on a grey surface&#10;&#10;AI-generated content may be incorrect.">
+            <a:extLst>
+              <a:ext uri="{FF2B5EF4-FFF2-40B4-BE49-F238E27FC236}">
+                <a16:creationId xmlns:a16="http://schemas.microsoft.com/office/drawing/2014/main" id="{CF13FD14-684D-9534-ADD5-4602E42C32A9}"/>
+              </a:ext>
+            </a:extLst>
+          </p:cNvPr>
+          <p:cNvPicPr>
+            <a:picLocks noGrp="1" noChangeAspect="1"/>
+          </p:cNvPicPr>
+          <p:nvPr>
+            <p:ph sz="quarter" idx="13"/>
+          </p:nvPr>
+        </p:nvPicPr>
+        <p:blipFill>
+          <a:blip r:embed="rId2"/>
+          <a:stretch>
+            <a:fillRect/>
+          </a:stretch>
+        </p:blipFill>
+        <p:spPr>
+          <a:xfrm>
+            <a:off x="1057719" y="1399032"/>
+            <a:ext cx="10076561" cy="5199890"/>
+          </a:xfrm>
+        </p:spPr>
+      </p:pic>
+      <p:sp>
+        <p:nvSpPr>
+          <p:cNvPr id="4" name="Slide Number Placeholder 3">
+            <a:extLst>
+              <a:ext uri="{FF2B5EF4-FFF2-40B4-BE49-F238E27FC236}">
+                <a16:creationId xmlns:a16="http://schemas.microsoft.com/office/drawing/2014/main" id="{576147E8-EEEA-FD84-15A1-473A51471464}"/>
+              </a:ext>
+            </a:extLst>
+          </p:cNvPr>
+          <p:cNvSpPr>
+            <a:spLocks noGrp="1"/>
+          </p:cNvSpPr>
+          <p:nvPr>
+            <p:ph type="sldNum" sz="quarter" idx="11"/>
+          </p:nvPr>
+        </p:nvSpPr>
+        <p:spPr/>
+        <p:txBody>
+          <a:bodyPr/>
+          <a:lstStyle/>
+          <a:p>
+            <a:fld id="{B67B645E-C5E5-4727-B977-D372A0AA71D9}" type="slidenum">
+              <a:rPr lang="en-US" smtClean="0"/>
+              <a:pPr/>
+              <a:t>17</a:t>
+            </a:fld>
+            <a:endParaRPr lang="en-US" dirty="0"/>
+          </a:p>
+        </p:txBody>
+      </p:sp>
+    </p:spTree>
+    <p:extLst>
+      <p:ext uri="{BB962C8B-B14F-4D97-AF65-F5344CB8AC3E}">
+        <p14:creationId xmlns:p14="http://schemas.microsoft.com/office/powerpoint/2010/main" val="3275669698"/>
+      </p:ext>
+    </p:extLst>
+  </p:cSld>
+  <p:clrMapOvr>
+    <a:masterClrMapping/>
+  </p:clrMapOvr>
+</p:sld>
+</file>
+
+<file path=ppt/slides/slide18.xml><?xml version="1.0" encoding="utf-8"?>
+<p:sld xmlns:a="http://schemas.openxmlformats.org/drawingml/2006/main" xmlns:r="http://schemas.openxmlformats.org/officeDocument/2006/relationships" xmlns:p="http://schemas.openxmlformats.org/presentationml/2006/main">
+  <p:cSld>
+    <p:spTree>
+      <p:nvGrpSpPr>
         <p:cNvPr id="1" name="">
           <a:extLst>
             <a:ext uri="{FF2B5EF4-FFF2-40B4-BE49-F238E27FC236}">
@@ -11579,7 +11815,7 @@
             <a:fld id="{B67B645E-C5E5-4727-B977-D372A0AA71D9}" type="slidenum">
               <a:rPr lang="en-US" smtClean="0"/>
               <a:pPr/>
-              <a:t>16</a:t>
+              <a:t>18</a:t>
             </a:fld>
             <a:endParaRPr lang="en-US" dirty="0"/>
           </a:p>
@@ -11628,7 +11864,7 @@
 </p:sld>
 </file>
 
-<file path=ppt/slides/slide17.xml><?xml version="1.0" encoding="utf-8"?>
+<file path=ppt/slides/slide19.xml><?xml version="1.0" encoding="utf-8"?>
 <p:sld xmlns:a="http://schemas.openxmlformats.org/drawingml/2006/main" xmlns:r="http://schemas.openxmlformats.org/officeDocument/2006/relationships" xmlns:p="http://schemas.openxmlformats.org/presentationml/2006/main">
   <p:cSld>
     <p:spTree>
@@ -11756,7 +11992,7 @@
             <a:fld id="{B67B645E-C5E5-4727-B977-D372A0AA71D9}" type="slidenum">
               <a:rPr lang="en-US" smtClean="0"/>
               <a:pPr/>
-              <a:t>17</a:t>
+              <a:t>19</a:t>
             </a:fld>
             <a:endParaRPr lang="en-US" dirty="0"/>
           </a:p>
@@ -11766,209 +12002,6 @@
     <p:extLst>
       <p:ext uri="{BB962C8B-B14F-4D97-AF65-F5344CB8AC3E}">
         <p14:creationId xmlns:p14="http://schemas.microsoft.com/office/powerpoint/2010/main" val="1809417748"/>
-      </p:ext>
-    </p:extLst>
-  </p:cSld>
-  <p:clrMapOvr>
-    <a:masterClrMapping/>
-  </p:clrMapOvr>
-</p:sld>
-</file>
-
-<file path=ppt/slides/slide18.xml><?xml version="1.0" encoding="utf-8"?>
-<p:sld xmlns:a="http://schemas.openxmlformats.org/drawingml/2006/main" xmlns:r="http://schemas.openxmlformats.org/officeDocument/2006/relationships" xmlns:p="http://schemas.openxmlformats.org/presentationml/2006/main">
-  <p:cSld>
-    <p:spTree>
-      <p:nvGrpSpPr>
-        <p:cNvPr id="1" name=""/>
-        <p:cNvGrpSpPr/>
-        <p:nvPr/>
-      </p:nvGrpSpPr>
-      <p:grpSpPr>
-        <a:xfrm>
-          <a:off x="0" y="0"/>
-          <a:ext cx="0" cy="0"/>
-          <a:chOff x="0" y="0"/>
-          <a:chExt cx="0" cy="0"/>
-        </a:xfrm>
-      </p:grpSpPr>
-      <p:sp>
-        <p:nvSpPr>
-          <p:cNvPr id="2" name="Title 1">
-            <a:extLst>
-              <a:ext uri="{FF2B5EF4-FFF2-40B4-BE49-F238E27FC236}">
-                <a16:creationId xmlns:a16="http://schemas.microsoft.com/office/drawing/2014/main" id="{E178EF87-E3BB-A226-DCCF-2D45CE9BE47B}"/>
-              </a:ext>
-            </a:extLst>
-          </p:cNvPr>
-          <p:cNvSpPr>
-            <a:spLocks noGrp="1"/>
-          </p:cNvSpPr>
-          <p:nvPr>
-            <p:ph type="title"/>
-          </p:nvPr>
-        </p:nvSpPr>
-        <p:spPr/>
-        <p:txBody>
-          <a:bodyPr/>
-          <a:lstStyle/>
-          <a:p>
-            <a:r>
-              <a:rPr lang="en-US" dirty="0"/>
-              <a:t>Immediate Plan</a:t>
-            </a:r>
-          </a:p>
-        </p:txBody>
-      </p:sp>
-      <p:sp>
-        <p:nvSpPr>
-          <p:cNvPr id="3" name="Content Placeholder 2">
-            <a:extLst>
-              <a:ext uri="{FF2B5EF4-FFF2-40B4-BE49-F238E27FC236}">
-                <a16:creationId xmlns:a16="http://schemas.microsoft.com/office/drawing/2014/main" id="{1F4E9115-94A4-A2F8-8B11-947907F62B45}"/>
-              </a:ext>
-            </a:extLst>
-          </p:cNvPr>
-          <p:cNvSpPr>
-            <a:spLocks noGrp="1"/>
-          </p:cNvSpPr>
-          <p:nvPr>
-            <p:ph sz="quarter" idx="13"/>
-          </p:nvPr>
-        </p:nvSpPr>
-        <p:spPr>
-          <a:xfrm>
-            <a:off x="841248" y="1536827"/>
-            <a:ext cx="10479024" cy="4479925"/>
-          </a:xfrm>
-        </p:spPr>
-        <p:txBody>
-          <a:bodyPr/>
-          <a:lstStyle/>
-          <a:p>
-            <a:r>
-              <a:rPr lang="en-US" dirty="0"/>
-              <a:t>Continue schematic and symbol creation</a:t>
-            </a:r>
-          </a:p>
-          <a:p>
-            <a:r>
-              <a:rPr lang="en-US" dirty="0"/>
-              <a:t>Find battery for device</a:t>
-            </a:r>
-          </a:p>
-          <a:p>
-            <a:r>
-              <a:rPr lang="en-US" dirty="0"/>
-              <a:t>Determine board measurements for housing</a:t>
-            </a:r>
-          </a:p>
-          <a:p>
-            <a:r>
-              <a:rPr lang="en-US" dirty="0"/>
-              <a:t>Code pairing and app integration</a:t>
-            </a:r>
-          </a:p>
-          <a:p>
-            <a:r>
-              <a:rPr lang="en-US" dirty="0"/>
-              <a:t>DDS Verification / DDS Breakout Board assembly</a:t>
-            </a:r>
-          </a:p>
-        </p:txBody>
-      </p:sp>
-      <p:sp>
-        <p:nvSpPr>
-          <p:cNvPr id="4" name="Slide Number Placeholder 3">
-            <a:extLst>
-              <a:ext uri="{FF2B5EF4-FFF2-40B4-BE49-F238E27FC236}">
-                <a16:creationId xmlns:a16="http://schemas.microsoft.com/office/drawing/2014/main" id="{305C2303-290B-35FB-A4CD-104764401AD5}"/>
-              </a:ext>
-            </a:extLst>
-          </p:cNvPr>
-          <p:cNvSpPr>
-            <a:spLocks noGrp="1"/>
-          </p:cNvSpPr>
-          <p:nvPr>
-            <p:ph type="sldNum" sz="quarter" idx="11"/>
-          </p:nvPr>
-        </p:nvSpPr>
-        <p:spPr/>
-        <p:txBody>
-          <a:bodyPr/>
-          <a:lstStyle/>
-          <a:p>
-            <a:fld id="{B67B645E-C5E5-4727-B977-D372A0AA71D9}" type="slidenum">
-              <a:rPr lang="en-US" smtClean="0"/>
-              <a:pPr/>
-              <a:t>18</a:t>
-            </a:fld>
-            <a:endParaRPr lang="en-US" dirty="0"/>
-          </a:p>
-        </p:txBody>
-      </p:sp>
-    </p:spTree>
-    <p:extLst>
-      <p:ext uri="{BB962C8B-B14F-4D97-AF65-F5344CB8AC3E}">
-        <p14:creationId xmlns:p14="http://schemas.microsoft.com/office/powerpoint/2010/main" val="3402217194"/>
-      </p:ext>
-    </p:extLst>
-  </p:cSld>
-  <p:clrMapOvr>
-    <a:masterClrMapping/>
-  </p:clrMapOvr>
-</p:sld>
-</file>
-
-<file path=ppt/slides/slide19.xml><?xml version="1.0" encoding="utf-8"?>
-<p:sld xmlns:a="http://schemas.openxmlformats.org/drawingml/2006/main" xmlns:r="http://schemas.openxmlformats.org/officeDocument/2006/relationships" xmlns:p="http://schemas.openxmlformats.org/presentationml/2006/main">
-  <p:cSld>
-    <p:spTree>
-      <p:nvGrpSpPr>
-        <p:cNvPr id="1" name=""/>
-        <p:cNvGrpSpPr/>
-        <p:nvPr/>
-      </p:nvGrpSpPr>
-      <p:grpSpPr>
-        <a:xfrm>
-          <a:off x="0" y="0"/>
-          <a:ext cx="0" cy="0"/>
-          <a:chOff x="0" y="0"/>
-          <a:chExt cx="0" cy="0"/>
-        </a:xfrm>
-      </p:grpSpPr>
-      <p:sp>
-        <p:nvSpPr>
-          <p:cNvPr id="28" name="Title 27">
-            <a:extLst>
-              <a:ext uri="{FF2B5EF4-FFF2-40B4-BE49-F238E27FC236}">
-                <a16:creationId xmlns:a16="http://schemas.microsoft.com/office/drawing/2014/main" id="{CC25EE42-B3D5-AD1E-48BE-54CEFF2E3D79}"/>
-              </a:ext>
-            </a:extLst>
-          </p:cNvPr>
-          <p:cNvSpPr>
-            <a:spLocks noGrp="1"/>
-          </p:cNvSpPr>
-          <p:nvPr>
-            <p:ph type="title"/>
-          </p:nvPr>
-        </p:nvSpPr>
-        <p:spPr/>
-        <p:txBody>
-          <a:bodyPr/>
-          <a:lstStyle/>
-          <a:p>
-            <a:r>
-              <a:rPr lang="en-US" dirty="0"/>
-              <a:t>Questions/Feedback</a:t>
-            </a:r>
-          </a:p>
-        </p:txBody>
-      </p:sp>
-    </p:spTree>
-    <p:extLst>
-      <p:ext uri="{BB962C8B-B14F-4D97-AF65-F5344CB8AC3E}">
-        <p14:creationId xmlns:p14="http://schemas.microsoft.com/office/powerpoint/2010/main" val="1988437062"/>
       </p:ext>
     </p:extLst>
   </p:cSld>
@@ -12106,6 +12139,209 @@
     <p:extLst>
       <p:ext uri="{BB962C8B-B14F-4D97-AF65-F5344CB8AC3E}">
         <p14:creationId xmlns:p14="http://schemas.microsoft.com/office/powerpoint/2010/main" val="4132634631"/>
+      </p:ext>
+    </p:extLst>
+  </p:cSld>
+  <p:clrMapOvr>
+    <a:masterClrMapping/>
+  </p:clrMapOvr>
+</p:sld>
+</file>
+
+<file path=ppt/slides/slide20.xml><?xml version="1.0" encoding="utf-8"?>
+<p:sld xmlns:a="http://schemas.openxmlformats.org/drawingml/2006/main" xmlns:r="http://schemas.openxmlformats.org/officeDocument/2006/relationships" xmlns:p="http://schemas.openxmlformats.org/presentationml/2006/main">
+  <p:cSld>
+    <p:spTree>
+      <p:nvGrpSpPr>
+        <p:cNvPr id="1" name=""/>
+        <p:cNvGrpSpPr/>
+        <p:nvPr/>
+      </p:nvGrpSpPr>
+      <p:grpSpPr>
+        <a:xfrm>
+          <a:off x="0" y="0"/>
+          <a:ext cx="0" cy="0"/>
+          <a:chOff x="0" y="0"/>
+          <a:chExt cx="0" cy="0"/>
+        </a:xfrm>
+      </p:grpSpPr>
+      <p:sp>
+        <p:nvSpPr>
+          <p:cNvPr id="2" name="Title 1">
+            <a:extLst>
+              <a:ext uri="{FF2B5EF4-FFF2-40B4-BE49-F238E27FC236}">
+                <a16:creationId xmlns:a16="http://schemas.microsoft.com/office/drawing/2014/main" id="{E178EF87-E3BB-A226-DCCF-2D45CE9BE47B}"/>
+              </a:ext>
+            </a:extLst>
+          </p:cNvPr>
+          <p:cNvSpPr>
+            <a:spLocks noGrp="1"/>
+          </p:cNvSpPr>
+          <p:nvPr>
+            <p:ph type="title"/>
+          </p:nvPr>
+        </p:nvSpPr>
+        <p:spPr/>
+        <p:txBody>
+          <a:bodyPr/>
+          <a:lstStyle/>
+          <a:p>
+            <a:r>
+              <a:rPr lang="en-US" dirty="0"/>
+              <a:t>Immediate Plan</a:t>
+            </a:r>
+          </a:p>
+        </p:txBody>
+      </p:sp>
+      <p:sp>
+        <p:nvSpPr>
+          <p:cNvPr id="3" name="Content Placeholder 2">
+            <a:extLst>
+              <a:ext uri="{FF2B5EF4-FFF2-40B4-BE49-F238E27FC236}">
+                <a16:creationId xmlns:a16="http://schemas.microsoft.com/office/drawing/2014/main" id="{1F4E9115-94A4-A2F8-8B11-947907F62B45}"/>
+              </a:ext>
+            </a:extLst>
+          </p:cNvPr>
+          <p:cNvSpPr>
+            <a:spLocks noGrp="1"/>
+          </p:cNvSpPr>
+          <p:nvPr>
+            <p:ph sz="quarter" idx="13"/>
+          </p:nvPr>
+        </p:nvSpPr>
+        <p:spPr>
+          <a:xfrm>
+            <a:off x="841248" y="1536827"/>
+            <a:ext cx="10479024" cy="4479925"/>
+          </a:xfrm>
+        </p:spPr>
+        <p:txBody>
+          <a:bodyPr/>
+          <a:lstStyle/>
+          <a:p>
+            <a:r>
+              <a:rPr lang="en-US" dirty="0"/>
+              <a:t>Continue schematic and symbol creation</a:t>
+            </a:r>
+          </a:p>
+          <a:p>
+            <a:r>
+              <a:rPr lang="en-US" dirty="0"/>
+              <a:t>Find battery for device</a:t>
+            </a:r>
+          </a:p>
+          <a:p>
+            <a:r>
+              <a:rPr lang="en-US" dirty="0"/>
+              <a:t>Determine board measurements for housing</a:t>
+            </a:r>
+          </a:p>
+          <a:p>
+            <a:r>
+              <a:rPr lang="en-US" dirty="0"/>
+              <a:t>Code pairing and app integration</a:t>
+            </a:r>
+          </a:p>
+          <a:p>
+            <a:r>
+              <a:rPr lang="en-US" dirty="0"/>
+              <a:t>DDS Verification / DDS Breakout Board assembly</a:t>
+            </a:r>
+          </a:p>
+        </p:txBody>
+      </p:sp>
+      <p:sp>
+        <p:nvSpPr>
+          <p:cNvPr id="4" name="Slide Number Placeholder 3">
+            <a:extLst>
+              <a:ext uri="{FF2B5EF4-FFF2-40B4-BE49-F238E27FC236}">
+                <a16:creationId xmlns:a16="http://schemas.microsoft.com/office/drawing/2014/main" id="{305C2303-290B-35FB-A4CD-104764401AD5}"/>
+              </a:ext>
+            </a:extLst>
+          </p:cNvPr>
+          <p:cNvSpPr>
+            <a:spLocks noGrp="1"/>
+          </p:cNvSpPr>
+          <p:nvPr>
+            <p:ph type="sldNum" sz="quarter" idx="11"/>
+          </p:nvPr>
+        </p:nvSpPr>
+        <p:spPr/>
+        <p:txBody>
+          <a:bodyPr/>
+          <a:lstStyle/>
+          <a:p>
+            <a:fld id="{B67B645E-C5E5-4727-B977-D372A0AA71D9}" type="slidenum">
+              <a:rPr lang="en-US" smtClean="0"/>
+              <a:pPr/>
+              <a:t>20</a:t>
+            </a:fld>
+            <a:endParaRPr lang="en-US" dirty="0"/>
+          </a:p>
+        </p:txBody>
+      </p:sp>
+    </p:spTree>
+    <p:extLst>
+      <p:ext uri="{BB962C8B-B14F-4D97-AF65-F5344CB8AC3E}">
+        <p14:creationId xmlns:p14="http://schemas.microsoft.com/office/powerpoint/2010/main" val="3402217194"/>
+      </p:ext>
+    </p:extLst>
+  </p:cSld>
+  <p:clrMapOvr>
+    <a:masterClrMapping/>
+  </p:clrMapOvr>
+</p:sld>
+</file>
+
+<file path=ppt/slides/slide21.xml><?xml version="1.0" encoding="utf-8"?>
+<p:sld xmlns:a="http://schemas.openxmlformats.org/drawingml/2006/main" xmlns:r="http://schemas.openxmlformats.org/officeDocument/2006/relationships" xmlns:p="http://schemas.openxmlformats.org/presentationml/2006/main">
+  <p:cSld>
+    <p:spTree>
+      <p:nvGrpSpPr>
+        <p:cNvPr id="1" name=""/>
+        <p:cNvGrpSpPr/>
+        <p:nvPr/>
+      </p:nvGrpSpPr>
+      <p:grpSpPr>
+        <a:xfrm>
+          <a:off x="0" y="0"/>
+          <a:ext cx="0" cy="0"/>
+          <a:chOff x="0" y="0"/>
+          <a:chExt cx="0" cy="0"/>
+        </a:xfrm>
+      </p:grpSpPr>
+      <p:sp>
+        <p:nvSpPr>
+          <p:cNvPr id="28" name="Title 27">
+            <a:extLst>
+              <a:ext uri="{FF2B5EF4-FFF2-40B4-BE49-F238E27FC236}">
+                <a16:creationId xmlns:a16="http://schemas.microsoft.com/office/drawing/2014/main" id="{CC25EE42-B3D5-AD1E-48BE-54CEFF2E3D79}"/>
+              </a:ext>
+            </a:extLst>
+          </p:cNvPr>
+          <p:cNvSpPr>
+            <a:spLocks noGrp="1"/>
+          </p:cNvSpPr>
+          <p:nvPr>
+            <p:ph type="title"/>
+          </p:nvPr>
+        </p:nvSpPr>
+        <p:spPr/>
+        <p:txBody>
+          <a:bodyPr/>
+          <a:lstStyle/>
+          <a:p>
+            <a:r>
+              <a:rPr lang="en-US" dirty="0"/>
+              <a:t>Questions/Feedback</a:t>
+            </a:r>
+          </a:p>
+        </p:txBody>
+      </p:sp>
+    </p:spTree>
+    <p:extLst>
+      <p:ext uri="{BB962C8B-B14F-4D97-AF65-F5344CB8AC3E}">
+        <p14:creationId xmlns:p14="http://schemas.microsoft.com/office/powerpoint/2010/main" val="1988437062"/>
       </p:ext>
     </p:extLst>
   </p:cSld>
@@ -19737,6 +19973,26 @@
 </file>
 
 <file path=customXml/item1.xml><?xml version="1.0" encoding="utf-8"?>
+<p:properties xmlns:p="http://schemas.microsoft.com/office/2006/metadata/properties" xmlns:xsi="http://www.w3.org/2001/XMLSchema-instance" xmlns:pc="http://schemas.microsoft.com/office/infopath/2007/PartnerControls">
+  <documentManagement>
+    <MediaServiceKeyPoints xmlns="71af3243-3dd4-4a8d-8c0d-dd76da1f02a5" xsi:nil="true"/>
+    <_ip_UnifiedCompliancePolicyUIAction xmlns="http://schemas.microsoft.com/sharepoint/v3" xsi:nil="true"/>
+    <Image xmlns="71af3243-3dd4-4a8d-8c0d-dd76da1f02a5">
+      <Url xsi:nil="true"/>
+      <Description xsi:nil="true"/>
+    </Image>
+    <Status xmlns="71af3243-3dd4-4a8d-8c0d-dd76da1f02a5">Not started</Status>
+    <Background xmlns="71af3243-3dd4-4a8d-8c0d-dd76da1f02a5">false</Background>
+    <_ip_UnifiedCompliancePolicyProperties xmlns="http://schemas.microsoft.com/sharepoint/v3" xsi:nil="true"/>
+    <ImageTagsTaxHTField xmlns="71af3243-3dd4-4a8d-8c0d-dd76da1f02a5">
+      <Terms xmlns="http://schemas.microsoft.com/office/infopath/2007/PartnerControls"/>
+    </ImageTagsTaxHTField>
+    <TaxCatchAll xmlns="230e9df3-be65-4c73-a93b-d1236ebd677e" xsi:nil="true"/>
+  </documentManagement>
+</p:properties>
+</file>
+
+<file path=customXml/item2.xml><?xml version="1.0" encoding="utf-8"?>
 <ct:contentTypeSchema xmlns:ct="http://schemas.microsoft.com/office/2006/metadata/contentType" xmlns:ma="http://schemas.microsoft.com/office/2006/metadata/properties/metaAttributes" ct:_="" ma:_="" ma:contentTypeName="Document" ma:contentTypeID="0x01010079F111ED35F8CC479449609E8A0923A6" ma:contentTypeVersion="29" ma:contentTypeDescription="Create a new document." ma:contentTypeScope="" ma:versionID="6a914531ae0f23be31da2eba1f3b42a9">
   <xsd:schema xmlns:xsd="http://www.w3.org/2001/XMLSchema" xmlns:xs="http://www.w3.org/2001/XMLSchema" xmlns:p="http://schemas.microsoft.com/office/2006/metadata/properties" xmlns:ns1="http://schemas.microsoft.com/sharepoint/v3" xmlns:ns2="71af3243-3dd4-4a8d-8c0d-dd76da1f02a5" xmlns:ns3="16c05727-aa75-4e4a-9b5f-8a80a1165891" xmlns:ns4="230e9df3-be65-4c73-a93b-d1236ebd677e" targetNamespace="http://schemas.microsoft.com/office/2006/metadata/properties" ma:root="true" ma:fieldsID="ae00154c9e66547f022c4923f88826d6" ns1:_="" ns2:_="" ns3:_="" ns4:_="">
     <xsd:import namespace="http://schemas.microsoft.com/sharepoint/v3"/>
@@ -20048,26 +20304,6 @@
 </ct:contentTypeSchema>
 </file>
 
-<file path=customXml/item2.xml><?xml version="1.0" encoding="utf-8"?>
-<p:properties xmlns:p="http://schemas.microsoft.com/office/2006/metadata/properties" xmlns:xsi="http://www.w3.org/2001/XMLSchema-instance" xmlns:pc="http://schemas.microsoft.com/office/infopath/2007/PartnerControls">
-  <documentManagement>
-    <MediaServiceKeyPoints xmlns="71af3243-3dd4-4a8d-8c0d-dd76da1f02a5" xsi:nil="true"/>
-    <_ip_UnifiedCompliancePolicyUIAction xmlns="http://schemas.microsoft.com/sharepoint/v3" xsi:nil="true"/>
-    <Image xmlns="71af3243-3dd4-4a8d-8c0d-dd76da1f02a5">
-      <Url xsi:nil="true"/>
-      <Description xsi:nil="true"/>
-    </Image>
-    <Status xmlns="71af3243-3dd4-4a8d-8c0d-dd76da1f02a5">Not started</Status>
-    <Background xmlns="71af3243-3dd4-4a8d-8c0d-dd76da1f02a5">false</Background>
-    <_ip_UnifiedCompliancePolicyProperties xmlns="http://schemas.microsoft.com/sharepoint/v3" xsi:nil="true"/>
-    <ImageTagsTaxHTField xmlns="71af3243-3dd4-4a8d-8c0d-dd76da1f02a5">
-      <Terms xmlns="http://schemas.microsoft.com/office/infopath/2007/PartnerControls"/>
-    </ImageTagsTaxHTField>
-    <TaxCatchAll xmlns="230e9df3-be65-4c73-a93b-d1236ebd677e" xsi:nil="true"/>
-  </documentManagement>
-</p:properties>
-</file>
-
 <file path=customXml/item3.xml><?xml version="1.0" encoding="utf-8"?>
 <?mso-contentType ?>
 <FormTemplates xmlns="http://schemas.microsoft.com/sharepoint/v3/contenttype/forms">
@@ -20078,6 +20314,18 @@
 </file>
 
 <file path=customXml/itemProps1.xml><?xml version="1.0" encoding="utf-8"?>
+<ds:datastoreItem xmlns:ds="http://schemas.openxmlformats.org/officeDocument/2006/customXml" ds:itemID="{7B247F30-5811-40C0-99EC-CF53200590BE}">
+  <ds:schemaRefs>
+    <ds:schemaRef ds:uri="230e9df3-be65-4c73-a93b-d1236ebd677e"/>
+    <ds:schemaRef ds:uri="71af3243-3dd4-4a8d-8c0d-dd76da1f02a5"/>
+    <ds:schemaRef ds:uri="http://schemas.microsoft.com/office/2006/metadata/properties"/>
+    <ds:schemaRef ds:uri="http://schemas.microsoft.com/office/infopath/2007/PartnerControls"/>
+    <ds:schemaRef ds:uri="http://schemas.microsoft.com/sharepoint/v3"/>
+  </ds:schemaRefs>
+</ds:datastoreItem>
+</file>
+
+<file path=customXml/itemProps2.xml><?xml version="1.0" encoding="utf-8"?>
 <ds:datastoreItem xmlns:ds="http://schemas.openxmlformats.org/officeDocument/2006/customXml" ds:itemID="{A8837B91-4329-4308-94DA-BB811B5F3092}">
   <ds:schemaRefs>
     <ds:schemaRef ds:uri="http://schemas.microsoft.com/office/2006/metadata/contentType"/>
@@ -20098,18 +20346,6 @@
 </ds:datastoreItem>
 </file>
 
-<file path=customXml/itemProps2.xml><?xml version="1.0" encoding="utf-8"?>
-<ds:datastoreItem xmlns:ds="http://schemas.openxmlformats.org/officeDocument/2006/customXml" ds:itemID="{7B247F30-5811-40C0-99EC-CF53200590BE}">
-  <ds:schemaRefs>
-    <ds:schemaRef ds:uri="230e9df3-be65-4c73-a93b-d1236ebd677e"/>
-    <ds:schemaRef ds:uri="71af3243-3dd4-4a8d-8c0d-dd76da1f02a5"/>
-    <ds:schemaRef ds:uri="http://schemas.microsoft.com/office/2006/metadata/properties"/>
-    <ds:schemaRef ds:uri="http://schemas.microsoft.com/office/infopath/2007/PartnerControls"/>
-    <ds:schemaRef ds:uri="http://schemas.microsoft.com/sharepoint/v3"/>
-  </ds:schemaRefs>
-</ds:datastoreItem>
-</file>
-
 <file path=customXml/itemProps3.xml><?xml version="1.0" encoding="utf-8"?>
 <ds:datastoreItem xmlns:ds="http://schemas.openxmlformats.org/officeDocument/2006/customXml" ds:itemID="{55E72E99-0076-433E-AD3A-575A11FAB73D}">
   <ds:schemaRefs>

</xml_diff>